<commit_message>
preparing figures and working out hollowing dynamics
</commit_message>
<xml_diff>
--- a/Sample code/Figure 6. Growth and ablation/Figure - growth_and_ablation.pptx
+++ b/Sample code/Figure 6. Growth and ablation/Figure - growth_and_ablation.pptx
@@ -243,7 +243,7 @@
           <a:p>
             <a:fld id="{7918679B-5683-0049-8DD0-2AC74A9489F6}" type="datetimeFigureOut">
               <a:rPr lang="en-US" smtClean="0"/>
-              <a:t>9/17/26</a:t>
+              <a:t>10/25/26</a:t>
             </a:fld>
             <a:endParaRPr lang="en-US"/>
           </a:p>
@@ -413,7 +413,7 @@
           <a:p>
             <a:fld id="{7918679B-5683-0049-8DD0-2AC74A9489F6}" type="datetimeFigureOut">
               <a:rPr lang="en-US" smtClean="0"/>
-              <a:t>9/17/26</a:t>
+              <a:t>10/25/26</a:t>
             </a:fld>
             <a:endParaRPr lang="en-US"/>
           </a:p>
@@ -593,7 +593,7 @@
           <a:p>
             <a:fld id="{7918679B-5683-0049-8DD0-2AC74A9489F6}" type="datetimeFigureOut">
               <a:rPr lang="en-US" smtClean="0"/>
-              <a:t>9/17/26</a:t>
+              <a:t>10/25/26</a:t>
             </a:fld>
             <a:endParaRPr lang="en-US"/>
           </a:p>
@@ -763,7 +763,7 @@
           <a:p>
             <a:fld id="{7918679B-5683-0049-8DD0-2AC74A9489F6}" type="datetimeFigureOut">
               <a:rPr lang="en-US" smtClean="0"/>
-              <a:t>9/17/26</a:t>
+              <a:t>10/25/26</a:t>
             </a:fld>
             <a:endParaRPr lang="en-US"/>
           </a:p>
@@ -1007,7 +1007,7 @@
           <a:p>
             <a:fld id="{7918679B-5683-0049-8DD0-2AC74A9489F6}" type="datetimeFigureOut">
               <a:rPr lang="en-US" smtClean="0"/>
-              <a:t>9/17/26</a:t>
+              <a:t>10/25/26</a:t>
             </a:fld>
             <a:endParaRPr lang="en-US"/>
           </a:p>
@@ -1239,7 +1239,7 @@
           <a:p>
             <a:fld id="{7918679B-5683-0049-8DD0-2AC74A9489F6}" type="datetimeFigureOut">
               <a:rPr lang="en-US" smtClean="0"/>
-              <a:t>9/17/26</a:t>
+              <a:t>10/25/26</a:t>
             </a:fld>
             <a:endParaRPr lang="en-US"/>
           </a:p>
@@ -1606,7 +1606,7 @@
           <a:p>
             <a:fld id="{7918679B-5683-0049-8DD0-2AC74A9489F6}" type="datetimeFigureOut">
               <a:rPr lang="en-US" smtClean="0"/>
-              <a:t>9/17/26</a:t>
+              <a:t>10/25/26</a:t>
             </a:fld>
             <a:endParaRPr lang="en-US"/>
           </a:p>
@@ -1724,7 +1724,7 @@
           <a:p>
             <a:fld id="{7918679B-5683-0049-8DD0-2AC74A9489F6}" type="datetimeFigureOut">
               <a:rPr lang="en-US" smtClean="0"/>
-              <a:t>9/17/26</a:t>
+              <a:t>10/25/26</a:t>
             </a:fld>
             <a:endParaRPr lang="en-US"/>
           </a:p>
@@ -1819,7 +1819,7 @@
           <a:p>
             <a:fld id="{7918679B-5683-0049-8DD0-2AC74A9489F6}" type="datetimeFigureOut">
               <a:rPr lang="en-US" smtClean="0"/>
-              <a:t>9/17/26</a:t>
+              <a:t>10/25/26</a:t>
             </a:fld>
             <a:endParaRPr lang="en-US"/>
           </a:p>
@@ -2096,7 +2096,7 @@
           <a:p>
             <a:fld id="{7918679B-5683-0049-8DD0-2AC74A9489F6}" type="datetimeFigureOut">
               <a:rPr lang="en-US" smtClean="0"/>
-              <a:t>9/17/26</a:t>
+              <a:t>10/25/26</a:t>
             </a:fld>
             <a:endParaRPr lang="en-US"/>
           </a:p>
@@ -2353,7 +2353,7 @@
           <a:p>
             <a:fld id="{7918679B-5683-0049-8DD0-2AC74A9489F6}" type="datetimeFigureOut">
               <a:rPr lang="en-US" smtClean="0"/>
-              <a:t>9/17/26</a:t>
+              <a:t>10/25/26</a:t>
             </a:fld>
             <a:endParaRPr lang="en-US"/>
           </a:p>
@@ -2566,7 +2566,7 @@
           <a:p>
             <a:fld id="{7918679B-5683-0049-8DD0-2AC74A9489F6}" type="datetimeFigureOut">
               <a:rPr lang="en-US" smtClean="0"/>
-              <a:t>9/17/26</a:t>
+              <a:t>10/25/26</a:t>
             </a:fld>
             <a:endParaRPr lang="en-US"/>
           </a:p>
@@ -3007,10 +3007,10 @@
           </p:nvGrpSpPr>
           <p:grpSpPr>
             <a:xfrm>
-              <a:off x="-2029931" y="1415111"/>
-              <a:ext cx="394139" cy="1874761"/>
-              <a:chOff x="2608372" y="868999"/>
-              <a:chExt cx="525518" cy="2499681"/>
+              <a:off x="-2029931" y="1630381"/>
+              <a:ext cx="394139" cy="1723274"/>
+              <a:chOff x="2608372" y="1156027"/>
+              <a:chExt cx="525518" cy="2297695"/>
             </a:xfrm>
           </p:grpSpPr>
           <p:sp>
@@ -3027,8 +3027,8 @@
             </p:nvSpPr>
             <p:spPr>
               <a:xfrm>
-                <a:off x="2608373" y="868999"/>
-                <a:ext cx="525517" cy="303520"/>
+                <a:off x="2608373" y="1156027"/>
+                <a:ext cx="525517" cy="303521"/>
               </a:xfrm>
               <a:prstGeom prst="rect">
                 <a:avLst/>
@@ -3080,7 +3080,7 @@
             </p:nvSpPr>
             <p:spPr>
               <a:xfrm>
-                <a:off x="2608372" y="3065160"/>
+                <a:off x="2608372" y="3150202"/>
                 <a:ext cx="525517" cy="303520"/>
               </a:xfrm>
               <a:prstGeom prst="rect">
@@ -3225,7 +3225,7 @@
         </p:nvSpPr>
         <p:spPr>
           <a:xfrm>
-            <a:off x="37373" y="4834688"/>
+            <a:off x="37373" y="4866218"/>
             <a:ext cx="519565" cy="300082"/>
           </a:xfrm>
           <a:prstGeom prst="rect">

</xml_diff>